<commit_message>
Clarify dbt testing in presentation
</commit_message>
<xml_diff>
--- a/presentation/product_profitability_workshop.pptx
+++ b/presentation/product_profitability_workshop.pptx
@@ -2,16 +2,16 @@
 <file path=ppt/presentation.xml><?xml version="1.0" encoding="utf-8"?>
 <p:presentation xmlns:p="http://schemas.openxmlformats.org/presentationml/2006/main">
   <p:sldMasterIdLst>
-    <p:sldMasterId xmlns:r="http://schemas.openxmlformats.org/officeDocument/2006/relationships" id="2147483648" r:id="R353c3b521bc04aaa"/>
+    <p:sldMasterId xmlns:r="http://schemas.openxmlformats.org/officeDocument/2006/relationships" id="2147483648" r:id="Rf632693ba177426b"/>
   </p:sldMasterIdLst>
   <p:notesMasterIdLst>
-    <p:notesMasterId xmlns:r="http://schemas.openxmlformats.org/officeDocument/2006/relationships" r:id="Raf588bca96e74fd4"/>
+    <p:notesMasterId xmlns:r="http://schemas.openxmlformats.org/officeDocument/2006/relationships" r:id="R5427f5c4b86e4cca"/>
   </p:notesMasterIdLst>
   <p:sldIdLst>
-    <p:sldId xmlns:r="http://schemas.openxmlformats.org/officeDocument/2006/relationships" id="256" r:id="Rc6fc54ccc410419a"/>
-    <p:sldId xmlns:r="http://schemas.openxmlformats.org/officeDocument/2006/relationships" id="257" r:id="R35ee8631dd4d4985"/>
-    <p:sldId xmlns:r="http://schemas.openxmlformats.org/officeDocument/2006/relationships" id="258" r:id="R263f700afdb84fa4"/>
-    <p:sldId xmlns:r="http://schemas.openxmlformats.org/officeDocument/2006/relationships" id="259" r:id="Rc19aec12b54944ae"/>
+    <p:sldId xmlns:r="http://schemas.openxmlformats.org/officeDocument/2006/relationships" id="256" r:id="R2c23284f885240c5"/>
+    <p:sldId xmlns:r="http://schemas.openxmlformats.org/officeDocument/2006/relationships" id="257" r:id="R6c49edd2bf214b9e"/>
+    <p:sldId xmlns:r="http://schemas.openxmlformats.org/officeDocument/2006/relationships" id="258" r:id="R42876b22b2214c5b"/>
+    <p:sldId xmlns:r="http://schemas.openxmlformats.org/officeDocument/2006/relationships" id="259" r:id="Ra1ad05a036dc48c2"/>
   </p:sldIdLst>
   <p:sldSz cx="12192000" cy="6858000"/>
   <p:notesSz cx="6858000" cy="9144000"/>
@@ -802,7 +802,7 @@
   </p:cSld>
   <p:clrMap bg1="lt1" tx1="dk1" bg2="lt2" tx2="dk2" accent1="accent1" accent2="accent2" accent3="accent3" accent4="accent4" accent5="accent5" accent6="accent6" hlink="hlink" folHlink="folHlink"/>
   <p:sldLayoutIdLst>
-    <p:sldLayoutId xmlns:r="http://schemas.openxmlformats.org/officeDocument/2006/relationships" id="2147483649" r:id="Rd4bd92b8fd5a47b1"/>
+    <p:sldLayoutId xmlns:r="http://schemas.openxmlformats.org/officeDocument/2006/relationships" id="2147483649" r:id="R87910878b34b4d2c"/>
   </p:sldLayoutIdLst>
   <p:txStyles>
     <p:titleStyle>
@@ -1721,7 +1721,7 @@
           <p:cNvPr id="1" name="top-accent">
             <a:extLst xmlns:a="http://schemas.openxmlformats.org/drawingml/2006/main">
               <a:ext uri="{FF2B5EF4-FFF2-40B4-BE49-F238E27FC236}">
-                <a16:creationId xmlns:a16="http://schemas.microsoft.com/office/drawing/2014/main" id="{322918E6-6EC9-4612-AB4B-F07B35E80513}"/>
+                <a16:creationId xmlns:a16="http://schemas.microsoft.com/office/drawing/2014/main" id="{05D27C8B-B1C3-471E-9797-75BF1BD37618}"/>
               </a:ext>
             </a:extLst>
           </p:cNvPr>
@@ -1754,7 +1754,7 @@
           <p:cNvPr id="2" name="bottom-accent">
             <a:extLst xmlns:a="http://schemas.openxmlformats.org/drawingml/2006/main">
               <a:ext uri="{FF2B5EF4-FFF2-40B4-BE49-F238E27FC236}">
-                <a16:creationId xmlns:a16="http://schemas.microsoft.com/office/drawing/2014/main" id="{62685578-0212-449D-A1D5-1E1C17335492}"/>
+                <a16:creationId xmlns:a16="http://schemas.microsoft.com/office/drawing/2014/main" id="{FB841818-4E16-4630-9F19-051F09FDB094}"/>
               </a:ext>
             </a:extLst>
           </p:cNvPr>
@@ -1787,7 +1787,7 @@
           <p:cNvPr id="3" name="eyebrow">
             <a:extLst xmlns:a="http://schemas.openxmlformats.org/drawingml/2006/main">
               <a:ext uri="{FF2B5EF4-FFF2-40B4-BE49-F238E27FC236}">
-                <a16:creationId xmlns:a16="http://schemas.microsoft.com/office/drawing/2014/main" id="{AFA28762-632F-41E8-9243-D8E9D64243DB}"/>
+                <a16:creationId xmlns:a16="http://schemas.microsoft.com/office/drawing/2014/main" id="{6FD3269D-E32B-4568-9206-83A77663E03B}"/>
               </a:ext>
             </a:extLst>
           </p:cNvPr>
@@ -1837,7 +1837,7 @@
           <p:cNvPr id="4" name="title">
             <a:extLst xmlns:a="http://schemas.openxmlformats.org/drawingml/2006/main">
               <a:ext uri="{FF2B5EF4-FFF2-40B4-BE49-F238E27FC236}">
-                <a16:creationId xmlns:a16="http://schemas.microsoft.com/office/drawing/2014/main" id="{66E2AB82-4288-4034-BE6F-3E64EB13E70D}"/>
+                <a16:creationId xmlns:a16="http://schemas.microsoft.com/office/drawing/2014/main" id="{0C909FAD-4133-49C9-94FB-951514ED87EF}"/>
               </a:ext>
             </a:extLst>
           </p:cNvPr>
@@ -1887,7 +1887,7 @@
           <p:cNvPr id="5" name="question">
             <a:extLst xmlns:a="http://schemas.openxmlformats.org/drawingml/2006/main">
               <a:ext uri="{FF2B5EF4-FFF2-40B4-BE49-F238E27FC236}">
-                <a16:creationId xmlns:a16="http://schemas.microsoft.com/office/drawing/2014/main" id="{9600CE07-3785-4773-B836-CD7293977A96}"/>
+                <a16:creationId xmlns:a16="http://schemas.microsoft.com/office/drawing/2014/main" id="{ACEA6671-5BE3-41EF-9C80-3568D95F3D39}"/>
               </a:ext>
             </a:extLst>
           </p:cNvPr>
@@ -1937,7 +1937,7 @@
           <p:cNvPr id="6" name="definition-rule">
             <a:extLst xmlns:a="http://schemas.openxmlformats.org/drawingml/2006/main">
               <a:ext uri="{FF2B5EF4-FFF2-40B4-BE49-F238E27FC236}">
-                <a16:creationId xmlns:a16="http://schemas.microsoft.com/office/drawing/2014/main" id="{1B2C93F5-27B5-4F09-A0AF-4255AEF1C520}"/>
+                <a16:creationId xmlns:a16="http://schemas.microsoft.com/office/drawing/2014/main" id="{0F1967EE-25E6-496D-9BE2-942D654B54DC}"/>
               </a:ext>
             </a:extLst>
           </p:cNvPr>
@@ -1970,7 +1970,7 @@
           <p:cNvPr id="7" name="definition">
             <a:extLst xmlns:a="http://schemas.openxmlformats.org/drawingml/2006/main">
               <a:ext uri="{FF2B5EF4-FFF2-40B4-BE49-F238E27FC236}">
-                <a16:creationId xmlns:a16="http://schemas.microsoft.com/office/drawing/2014/main" id="{EBCB9F70-D51E-4ACD-88EB-2DF04E3C4645}"/>
+                <a16:creationId xmlns:a16="http://schemas.microsoft.com/office/drawing/2014/main" id="{14ADF980-8B78-4C3E-8C7D-438EE1189238}"/>
               </a:ext>
             </a:extLst>
           </p:cNvPr>
@@ -2020,7 +2020,7 @@
           <p:cNvPr id="8" name="caveat">
             <a:extLst xmlns:a="http://schemas.openxmlformats.org/drawingml/2006/main">
               <a:ext uri="{FF2B5EF4-FFF2-40B4-BE49-F238E27FC236}">
-                <a16:creationId xmlns:a16="http://schemas.microsoft.com/office/drawing/2014/main" id="{7EFEE6C5-B927-4894-873E-72B7DF577C6A}"/>
+                <a16:creationId xmlns:a16="http://schemas.microsoft.com/office/drawing/2014/main" id="{BF7DB10B-E862-4F5A-808E-65F04A44E5AD}"/>
               </a:ext>
             </a:extLst>
           </p:cNvPr>
@@ -2070,7 +2070,7 @@
           <p:cNvPr id="9" name="metric-items sold">
             <a:extLst xmlns:a="http://schemas.openxmlformats.org/drawingml/2006/main">
               <a:ext uri="{FF2B5EF4-FFF2-40B4-BE49-F238E27FC236}">
-                <a16:creationId xmlns:a16="http://schemas.microsoft.com/office/drawing/2014/main" id="{D522C312-6FCD-4AE1-9532-E329BC4F539F}"/>
+                <a16:creationId xmlns:a16="http://schemas.microsoft.com/office/drawing/2014/main" id="{90DE1EAD-1CE3-427D-A4A0-DDD4E67D649F}"/>
               </a:ext>
             </a:extLst>
           </p:cNvPr>
@@ -2120,7 +2120,7 @@
           <p:cNvPr id="10" name="metric-label-items sold">
             <a:extLst xmlns:a="http://schemas.openxmlformats.org/drawingml/2006/main">
               <a:ext uri="{FF2B5EF4-FFF2-40B4-BE49-F238E27FC236}">
-                <a16:creationId xmlns:a16="http://schemas.microsoft.com/office/drawing/2014/main" id="{69CA55A6-9C8A-4057-A1EB-A218048A775F}"/>
+                <a16:creationId xmlns:a16="http://schemas.microsoft.com/office/drawing/2014/main" id="{53B29E19-D24F-4903-9CE1-11AAE5D068C4}"/>
               </a:ext>
             </a:extLst>
           </p:cNvPr>
@@ -2170,7 +2170,7 @@
           <p:cNvPr id="11" name="metric-item revenue">
             <a:extLst xmlns:a="http://schemas.openxmlformats.org/drawingml/2006/main">
               <a:ext uri="{FF2B5EF4-FFF2-40B4-BE49-F238E27FC236}">
-                <a16:creationId xmlns:a16="http://schemas.microsoft.com/office/drawing/2014/main" id="{65320D33-D0AF-450C-BCA4-A71FA140CB07}"/>
+                <a16:creationId xmlns:a16="http://schemas.microsoft.com/office/drawing/2014/main" id="{7736D259-B363-4BEC-A69D-060B5F469D28}"/>
               </a:ext>
             </a:extLst>
           </p:cNvPr>
@@ -2220,7 +2220,7 @@
           <p:cNvPr id="12" name="metric-label-item revenue">
             <a:extLst xmlns:a="http://schemas.openxmlformats.org/drawingml/2006/main">
               <a:ext uri="{FF2B5EF4-FFF2-40B4-BE49-F238E27FC236}">
-                <a16:creationId xmlns:a16="http://schemas.microsoft.com/office/drawing/2014/main" id="{EA88F7CC-46D4-4A3D-A7A2-CDA6654295FC}"/>
+                <a16:creationId xmlns:a16="http://schemas.microsoft.com/office/drawing/2014/main" id="{E8B21140-9D49-4784-A9E6-543EFEFBFEB5}"/>
               </a:ext>
             </a:extLst>
           </p:cNvPr>
@@ -2270,7 +2270,7 @@
           <p:cNvPr id="13" name="metric-modeled gross profit">
             <a:extLst xmlns:a="http://schemas.openxmlformats.org/drawingml/2006/main">
               <a:ext uri="{FF2B5EF4-FFF2-40B4-BE49-F238E27FC236}">
-                <a16:creationId xmlns:a16="http://schemas.microsoft.com/office/drawing/2014/main" id="{4193154E-74FE-4125-9D70-AD8842D7788D}"/>
+                <a16:creationId xmlns:a16="http://schemas.microsoft.com/office/drawing/2014/main" id="{DCB46ED3-0779-4570-B4EE-33E31973C8DD}"/>
               </a:ext>
             </a:extLst>
           </p:cNvPr>
@@ -2320,7 +2320,7 @@
           <p:cNvPr id="14" name="metric-label-modeled gross profit">
             <a:extLst xmlns:a="http://schemas.openxmlformats.org/drawingml/2006/main">
               <a:ext uri="{FF2B5EF4-FFF2-40B4-BE49-F238E27FC236}">
-                <a16:creationId xmlns:a16="http://schemas.microsoft.com/office/drawing/2014/main" id="{7793892A-8F46-4FD5-BD1C-41A28AADEBB4}"/>
+                <a16:creationId xmlns:a16="http://schemas.microsoft.com/office/drawing/2014/main" id="{3FF3E9B7-8B58-4649-BB87-9E014D655C97}"/>
               </a:ext>
             </a:extLst>
           </p:cNvPr>
@@ -2370,7 +2370,7 @@
           <p:cNvPr id="15" name="footer-rule">
             <a:extLst xmlns:a="http://schemas.openxmlformats.org/drawingml/2006/main">
               <a:ext uri="{FF2B5EF4-FFF2-40B4-BE49-F238E27FC236}">
-                <a16:creationId xmlns:a16="http://schemas.microsoft.com/office/drawing/2014/main" id="{DC3870BC-4CB8-4E1D-8AA4-0BDA1922209E}"/>
+                <a16:creationId xmlns:a16="http://schemas.microsoft.com/office/drawing/2014/main" id="{F7AB98BD-1676-485B-979B-4D94A63C4DB2}"/>
               </a:ext>
             </a:extLst>
           </p:cNvPr>
@@ -2403,7 +2403,7 @@
           <p:cNvPr id="16" name="footer">
             <a:extLst xmlns:a="http://schemas.openxmlformats.org/drawingml/2006/main">
               <a:ext uri="{FF2B5EF4-FFF2-40B4-BE49-F238E27FC236}">
-                <a16:creationId xmlns:a16="http://schemas.microsoft.com/office/drawing/2014/main" id="{CB9BEAD0-3120-4F20-97D8-38F41109CE40}"/>
+                <a16:creationId xmlns:a16="http://schemas.microsoft.com/office/drawing/2014/main" id="{AB822698-52EE-4025-942B-A8EBF9234558}"/>
               </a:ext>
             </a:extLst>
           </p:cNvPr>
@@ -2451,7 +2451,7 @@
     </p:spTree>
     <p:extLst>
       <p:ext uri="{BB962C8B-B14F-4D97-AF65-F5344CB8AC3E}">
-        <p14:creationId xmlns:p14="http://schemas.microsoft.com/office/powerpoint/2010/main" val="288508440"/>
+        <p14:creationId xmlns:p14="http://schemas.microsoft.com/office/powerpoint/2010/main" val="708215645"/>
       </p:ext>
     </p:extLst>
   </p:cSld>
@@ -2482,7 +2482,7 @@
           <p:cNvPr id="1" name="top-accent">
             <a:extLst xmlns:a="http://schemas.openxmlformats.org/drawingml/2006/main">
               <a:ext uri="{FF2B5EF4-FFF2-40B4-BE49-F238E27FC236}">
-                <a16:creationId xmlns:a16="http://schemas.microsoft.com/office/drawing/2014/main" id="{F3E34F03-3935-4D77-9ECC-4250CAB398AE}"/>
+                <a16:creationId xmlns:a16="http://schemas.microsoft.com/office/drawing/2014/main" id="{7F0BAFBC-2C2F-43E2-BE2C-F3097B34AD8D}"/>
               </a:ext>
             </a:extLst>
           </p:cNvPr>
@@ -2515,7 +2515,7 @@
           <p:cNvPr id="2" name="bottom-accent">
             <a:extLst xmlns:a="http://schemas.openxmlformats.org/drawingml/2006/main">
               <a:ext uri="{FF2B5EF4-FFF2-40B4-BE49-F238E27FC236}">
-                <a16:creationId xmlns:a16="http://schemas.microsoft.com/office/drawing/2014/main" id="{9B34A233-3BBB-43BE-A35F-4A5DE4152A79}"/>
+                <a16:creationId xmlns:a16="http://schemas.microsoft.com/office/drawing/2014/main" id="{EA42117C-24D8-4951-8B90-2BD3CF84BDE9}"/>
               </a:ext>
             </a:extLst>
           </p:cNvPr>
@@ -2548,7 +2548,7 @@
           <p:cNvPr id="3" name="title">
             <a:extLst xmlns:a="http://schemas.openxmlformats.org/drawingml/2006/main">
               <a:ext uri="{FF2B5EF4-FFF2-40B4-BE49-F238E27FC236}">
-                <a16:creationId xmlns:a16="http://schemas.microsoft.com/office/drawing/2014/main" id="{E10E3727-06A8-4E09-800E-4A57E8A5C343}"/>
+                <a16:creationId xmlns:a16="http://schemas.microsoft.com/office/drawing/2014/main" id="{ECEFFFB9-7BC9-4018-A5BB-58F92407EFE3}"/>
               </a:ext>
             </a:extLst>
           </p:cNvPr>
@@ -2598,7 +2598,7 @@
           <p:cNvPr id="4" name="subtitle">
             <a:extLst xmlns:a="http://schemas.openxmlformats.org/drawingml/2006/main">
               <a:ext uri="{FF2B5EF4-FFF2-40B4-BE49-F238E27FC236}">
-                <a16:creationId xmlns:a16="http://schemas.microsoft.com/office/drawing/2014/main" id="{18A285B7-5C95-488B-852A-B98CE60421AA}"/>
+                <a16:creationId xmlns:a16="http://schemas.microsoft.com/office/drawing/2014/main" id="{349FBB63-E28F-4411-8ADA-DBF28E64329E}"/>
               </a:ext>
             </a:extLst>
           </p:cNvPr>
@@ -2652,7 +2652,7 @@
           <p:nvPr/>
         </p:nvPicPr>
         <p:blipFill>
-          <a:blip xmlns:r="http://schemas.openxmlformats.org/officeDocument/2006/relationships" xmlns:a="http://schemas.openxmlformats.org/drawingml/2006/main" r:embed="R0154edfecc7e4acd"/>
+          <a:blip xmlns:r="http://schemas.openxmlformats.org/officeDocument/2006/relationships" xmlns:a="http://schemas.openxmlformats.org/drawingml/2006/main" r:embed="R19459807349745ed"/>
           <a:stretch xmlns:a="http://schemas.openxmlformats.org/drawingml/2006/main"/>
         </p:blipFill>
         <p:spPr>
@@ -2672,7 +2672,7 @@
           <p:cNvPr id="6" name="footer-rule">
             <a:extLst xmlns:a="http://schemas.openxmlformats.org/drawingml/2006/main">
               <a:ext uri="{FF2B5EF4-FFF2-40B4-BE49-F238E27FC236}">
-                <a16:creationId xmlns:a16="http://schemas.microsoft.com/office/drawing/2014/main" id="{75BA8659-B12B-4142-A53C-ED851B18C855}"/>
+                <a16:creationId xmlns:a16="http://schemas.microsoft.com/office/drawing/2014/main" id="{03520DEF-A693-46C5-A0F5-DF7756E4357B}"/>
               </a:ext>
             </a:extLst>
           </p:cNvPr>
@@ -2705,7 +2705,7 @@
           <p:cNvPr id="7" name="footer">
             <a:extLst xmlns:a="http://schemas.openxmlformats.org/drawingml/2006/main">
               <a:ext uri="{FF2B5EF4-FFF2-40B4-BE49-F238E27FC236}">
-                <a16:creationId xmlns:a16="http://schemas.microsoft.com/office/drawing/2014/main" id="{3734FF4B-0868-4B86-87CD-C7A5B66BB849}"/>
+                <a16:creationId xmlns:a16="http://schemas.microsoft.com/office/drawing/2014/main" id="{3C174D2D-73A0-450C-BC0F-EDEC33704C46}"/>
               </a:ext>
             </a:extLst>
           </p:cNvPr>
@@ -2753,7 +2753,7 @@
     </p:spTree>
     <p:extLst>
       <p:ext uri="{BB962C8B-B14F-4D97-AF65-F5344CB8AC3E}">
-        <p14:creationId xmlns:p14="http://schemas.microsoft.com/office/powerpoint/2010/main" val="1259289879"/>
+        <p14:creationId xmlns:p14="http://schemas.microsoft.com/office/powerpoint/2010/main" val="1063896913"/>
       </p:ext>
     </p:extLst>
   </p:cSld>
@@ -2784,7 +2784,7 @@
           <p:cNvPr id="1" name="top-accent">
             <a:extLst xmlns:a="http://schemas.openxmlformats.org/drawingml/2006/main">
               <a:ext uri="{FF2B5EF4-FFF2-40B4-BE49-F238E27FC236}">
-                <a16:creationId xmlns:a16="http://schemas.microsoft.com/office/drawing/2014/main" id="{BA3B0977-CD07-4A38-B61A-C12D44815EB7}"/>
+                <a16:creationId xmlns:a16="http://schemas.microsoft.com/office/drawing/2014/main" id="{6A14F74E-EA1D-43F2-9975-A3C5ADA17053}"/>
               </a:ext>
             </a:extLst>
           </p:cNvPr>
@@ -2817,7 +2817,7 @@
           <p:cNvPr id="2" name="bottom-accent">
             <a:extLst xmlns:a="http://schemas.openxmlformats.org/drawingml/2006/main">
               <a:ext uri="{FF2B5EF4-FFF2-40B4-BE49-F238E27FC236}">
-                <a16:creationId xmlns:a16="http://schemas.microsoft.com/office/drawing/2014/main" id="{03D672E7-05EF-4151-A300-396D77CE5BBA}"/>
+                <a16:creationId xmlns:a16="http://schemas.microsoft.com/office/drawing/2014/main" id="{19B69322-2429-456C-829C-C2A650F6AD3A}"/>
               </a:ext>
             </a:extLst>
           </p:cNvPr>
@@ -2850,7 +2850,7 @@
           <p:cNvPr id="3" name="title">
             <a:extLst xmlns:a="http://schemas.openxmlformats.org/drawingml/2006/main">
               <a:ext uri="{FF2B5EF4-FFF2-40B4-BE49-F238E27FC236}">
-                <a16:creationId xmlns:a16="http://schemas.microsoft.com/office/drawing/2014/main" id="{E0E9B643-ADA3-4CDE-9D9F-3D8E9A262FB7}"/>
+                <a16:creationId xmlns:a16="http://schemas.microsoft.com/office/drawing/2014/main" id="{25B1E63C-50F2-4018-8A21-4A9660750794}"/>
               </a:ext>
             </a:extLst>
           </p:cNvPr>
@@ -2900,7 +2900,7 @@
           <p:cNvPr id="4" name="subtitle">
             <a:extLst xmlns:a="http://schemas.openxmlformats.org/drawingml/2006/main">
               <a:ext uri="{FF2B5EF4-FFF2-40B4-BE49-F238E27FC236}">
-                <a16:creationId xmlns:a16="http://schemas.microsoft.com/office/drawing/2014/main" id="{E8391390-463D-4115-82A1-6576764003AB}"/>
+                <a16:creationId xmlns:a16="http://schemas.microsoft.com/office/drawing/2014/main" id="{BEB74C21-B650-4FD4-B6AE-3D5DF7D9A423}"/>
               </a:ext>
             </a:extLst>
           </p:cNvPr>
@@ -2957,7 +2957,7 @@
         </p:xfrm>
         <a:graphic xmlns:a="http://schemas.openxmlformats.org/drawingml/2006/main">
           <a:graphicData uri="http://schemas.openxmlformats.org/drawingml/2006/chart">
-            <c:chart xmlns:r="http://schemas.openxmlformats.org/officeDocument/2006/relationships" xmlns:c="http://schemas.openxmlformats.org/drawingml/2006/chart" r:id="R7223a7ebc00d425c"/>
+            <c:chart xmlns:r="http://schemas.openxmlformats.org/officeDocument/2006/relationships" xmlns:c="http://schemas.openxmlformats.org/drawingml/2006/chart" r:id="Rc1313aaa06f5457d"/>
           </a:graphicData>
         </a:graphic>
       </p:graphicFrame>
@@ -2966,7 +2966,7 @@
           <p:cNvPr id="6" name="bev-label">
             <a:extLst xmlns:a="http://schemas.openxmlformats.org/drawingml/2006/main">
               <a:ext uri="{FF2B5EF4-FFF2-40B4-BE49-F238E27FC236}">
-                <a16:creationId xmlns:a16="http://schemas.microsoft.com/office/drawing/2014/main" id="{EDBE88C0-0FA9-4329-91D1-48533623BE45}"/>
+                <a16:creationId xmlns:a16="http://schemas.microsoft.com/office/drawing/2014/main" id="{ECCAAB75-D9E9-43BE-A394-59C26D6011CC}"/>
               </a:ext>
             </a:extLst>
           </p:cNvPr>
@@ -3016,7 +3016,7 @@
           <p:cNvPr id="7" name="bev-detail">
             <a:extLst xmlns:a="http://schemas.openxmlformats.org/drawingml/2006/main">
               <a:ext uri="{FF2B5EF4-FFF2-40B4-BE49-F238E27FC236}">
-                <a16:creationId xmlns:a16="http://schemas.microsoft.com/office/drawing/2014/main" id="{628B6811-7CB5-4BC3-B974-41897E6306CF}"/>
+                <a16:creationId xmlns:a16="http://schemas.microsoft.com/office/drawing/2014/main" id="{DB1E8763-2945-4426-BE6F-CF301CACC989}"/>
               </a:ext>
             </a:extLst>
           </p:cNvPr>
@@ -3100,7 +3100,7 @@
           <p:cNvPr id="8" name="">
             <a:extLst xmlns:a="http://schemas.openxmlformats.org/drawingml/2006/main">
               <a:ext uri="{FF2B5EF4-FFF2-40B4-BE49-F238E27FC236}">
-                <a16:creationId xmlns:a16="http://schemas.microsoft.com/office/drawing/2014/main" id="{881B1006-40C0-4AF5-ADAA-6575414F3D1A}"/>
+                <a16:creationId xmlns:a16="http://schemas.microsoft.com/office/drawing/2014/main" id="{0C20FCC0-C1FC-4D8C-B2D9-C3E2BF35F03A}"/>
               </a:ext>
             </a:extLst>
           </p:cNvPr>
@@ -3133,7 +3133,7 @@
           <p:cNvPr id="9" name="jaf-label">
             <a:extLst xmlns:a="http://schemas.openxmlformats.org/drawingml/2006/main">
               <a:ext uri="{FF2B5EF4-FFF2-40B4-BE49-F238E27FC236}">
-                <a16:creationId xmlns:a16="http://schemas.microsoft.com/office/drawing/2014/main" id="{2DA207E4-A0BC-4908-8806-33E66948BB6F}"/>
+                <a16:creationId xmlns:a16="http://schemas.microsoft.com/office/drawing/2014/main" id="{0B7585C3-7D9E-406F-A3F2-64C489E3FFF1}"/>
               </a:ext>
             </a:extLst>
           </p:cNvPr>
@@ -3183,7 +3183,7 @@
           <p:cNvPr id="10" name="jaf-detail">
             <a:extLst xmlns:a="http://schemas.openxmlformats.org/drawingml/2006/main">
               <a:ext uri="{FF2B5EF4-FFF2-40B4-BE49-F238E27FC236}">
-                <a16:creationId xmlns:a16="http://schemas.microsoft.com/office/drawing/2014/main" id="{281C6187-D07A-4700-9304-0E56E268440D}"/>
+                <a16:creationId xmlns:a16="http://schemas.microsoft.com/office/drawing/2014/main" id="{9554AB3B-74E6-4E82-80A3-BA0E919699B9}"/>
               </a:ext>
             </a:extLst>
           </p:cNvPr>
@@ -3250,7 +3250,7 @@
           <p:cNvPr id="11" name="period">
             <a:extLst xmlns:a="http://schemas.openxmlformats.org/drawingml/2006/main">
               <a:ext uri="{FF2B5EF4-FFF2-40B4-BE49-F238E27FC236}">
-                <a16:creationId xmlns:a16="http://schemas.microsoft.com/office/drawing/2014/main" id="{64930C16-FEE6-4B20-B83C-7FCC1EF93DCF}"/>
+                <a16:creationId xmlns:a16="http://schemas.microsoft.com/office/drawing/2014/main" id="{C1EE27D0-B8D8-4F14-8ADE-419C84696596}"/>
               </a:ext>
             </a:extLst>
           </p:cNvPr>
@@ -3300,7 +3300,7 @@
           <p:cNvPr id="12" name="footer-rule">
             <a:extLst xmlns:a="http://schemas.openxmlformats.org/drawingml/2006/main">
               <a:ext uri="{FF2B5EF4-FFF2-40B4-BE49-F238E27FC236}">
-                <a16:creationId xmlns:a16="http://schemas.microsoft.com/office/drawing/2014/main" id="{D72DC5CC-B379-4AD3-8305-A13AFA5934AE}"/>
+                <a16:creationId xmlns:a16="http://schemas.microsoft.com/office/drawing/2014/main" id="{7E6D5878-EFF0-43B9-B5F6-B299CB35AAB3}"/>
               </a:ext>
             </a:extLst>
           </p:cNvPr>
@@ -3333,7 +3333,7 @@
           <p:cNvPr id="13" name="footer">
             <a:extLst xmlns:a="http://schemas.openxmlformats.org/drawingml/2006/main">
               <a:ext uri="{FF2B5EF4-FFF2-40B4-BE49-F238E27FC236}">
-                <a16:creationId xmlns:a16="http://schemas.microsoft.com/office/drawing/2014/main" id="{7E004F86-EF94-42FE-A164-51E35B4842C4}"/>
+                <a16:creationId xmlns:a16="http://schemas.microsoft.com/office/drawing/2014/main" id="{ECD64C5B-4F1C-4905-8578-1C2538D715E3}"/>
               </a:ext>
             </a:extLst>
           </p:cNvPr>
@@ -3381,7 +3381,7 @@
     </p:spTree>
     <p:extLst>
       <p:ext uri="{BB962C8B-B14F-4D97-AF65-F5344CB8AC3E}">
-        <p14:creationId xmlns:p14="http://schemas.microsoft.com/office/powerpoint/2010/main" val="2097508173"/>
+        <p14:creationId xmlns:p14="http://schemas.microsoft.com/office/powerpoint/2010/main" val="853090894"/>
       </p:ext>
     </p:extLst>
   </p:cSld>
@@ -3412,7 +3412,7 @@
           <p:cNvPr id="1" name="top-accent">
             <a:extLst xmlns:a="http://schemas.openxmlformats.org/drawingml/2006/main">
               <a:ext uri="{FF2B5EF4-FFF2-40B4-BE49-F238E27FC236}">
-                <a16:creationId xmlns:a16="http://schemas.microsoft.com/office/drawing/2014/main" id="{AA8D011E-5F75-4A20-9310-C44B96AC15CA}"/>
+                <a16:creationId xmlns:a16="http://schemas.microsoft.com/office/drawing/2014/main" id="{04C1D86D-01F0-4242-961D-BB3D7CBC97CA}"/>
               </a:ext>
             </a:extLst>
           </p:cNvPr>
@@ -3445,7 +3445,7 @@
           <p:cNvPr id="2" name="bottom-accent">
             <a:extLst xmlns:a="http://schemas.openxmlformats.org/drawingml/2006/main">
               <a:ext uri="{FF2B5EF4-FFF2-40B4-BE49-F238E27FC236}">
-                <a16:creationId xmlns:a16="http://schemas.microsoft.com/office/drawing/2014/main" id="{00DDE304-1C2D-4F35-80E0-DE51058B4F94}"/>
+                <a16:creationId xmlns:a16="http://schemas.microsoft.com/office/drawing/2014/main" id="{64F9D52D-3CEE-413D-AA59-2DC32BE669DE}"/>
               </a:ext>
             </a:extLst>
           </p:cNvPr>
@@ -3478,7 +3478,7 @@
           <p:cNvPr id="3" name="title">
             <a:extLst xmlns:a="http://schemas.openxmlformats.org/drawingml/2006/main">
               <a:ext uri="{FF2B5EF4-FFF2-40B4-BE49-F238E27FC236}">
-                <a16:creationId xmlns:a16="http://schemas.microsoft.com/office/drawing/2014/main" id="{64550EF9-C15D-4759-BD18-0CE9DB7D942A}"/>
+                <a16:creationId xmlns:a16="http://schemas.microsoft.com/office/drawing/2014/main" id="{06E96EE9-D3BE-4FD9-80D3-3E3ED099DB0B}"/>
               </a:ext>
             </a:extLst>
           </p:cNvPr>
@@ -3528,7 +3528,7 @@
           <p:cNvPr id="4" name="step1-num">
             <a:extLst xmlns:a="http://schemas.openxmlformats.org/drawingml/2006/main">
               <a:ext uri="{FF2B5EF4-FFF2-40B4-BE49-F238E27FC236}">
-                <a16:creationId xmlns:a16="http://schemas.microsoft.com/office/drawing/2014/main" id="{A9EDE88F-C444-4D3D-8B7F-1BAACF589D6D}"/>
+                <a16:creationId xmlns:a16="http://schemas.microsoft.com/office/drawing/2014/main" id="{506BF5B4-DDD4-457F-A466-80D4E0CF4BB3}"/>
               </a:ext>
             </a:extLst>
           </p:cNvPr>
@@ -3578,7 +3578,7 @@
           <p:cNvPr id="5" name="step1-title">
             <a:extLst xmlns:a="http://schemas.openxmlformats.org/drawingml/2006/main">
               <a:ext uri="{FF2B5EF4-FFF2-40B4-BE49-F238E27FC236}">
-                <a16:creationId xmlns:a16="http://schemas.microsoft.com/office/drawing/2014/main" id="{523C3A45-3385-40E7-8BB8-AE46C97A66FD}"/>
+                <a16:creationId xmlns:a16="http://schemas.microsoft.com/office/drawing/2014/main" id="{A54C56D0-4426-4CF2-9800-08147F017EF4}"/>
               </a:ext>
             </a:extLst>
           </p:cNvPr>
@@ -3628,7 +3628,7 @@
           <p:cNvPr id="6" name="step1-copy">
             <a:extLst xmlns:a="http://schemas.openxmlformats.org/drawingml/2006/main">
               <a:ext uri="{FF2B5EF4-FFF2-40B4-BE49-F238E27FC236}">
-                <a16:creationId xmlns:a16="http://schemas.microsoft.com/office/drawing/2014/main" id="{93E2047B-85B1-4151-B49B-732BA9712646}"/>
+                <a16:creationId xmlns:a16="http://schemas.microsoft.com/office/drawing/2014/main" id="{85C5F887-D462-435E-B420-153822116F8C}"/>
               </a:ext>
             </a:extLst>
           </p:cNvPr>
@@ -3678,7 +3678,7 @@
           <p:cNvPr id="7" name="step2-num">
             <a:extLst xmlns:a="http://schemas.openxmlformats.org/drawingml/2006/main">
               <a:ext uri="{FF2B5EF4-FFF2-40B4-BE49-F238E27FC236}">
-                <a16:creationId xmlns:a16="http://schemas.microsoft.com/office/drawing/2014/main" id="{EC0B1738-3F02-4AE0-9F16-4731AE8FED10}"/>
+                <a16:creationId xmlns:a16="http://schemas.microsoft.com/office/drawing/2014/main" id="{A5F32145-DB55-491C-90FC-CA3471FE699B}"/>
               </a:ext>
             </a:extLst>
           </p:cNvPr>
@@ -3728,7 +3728,7 @@
           <p:cNvPr id="8" name="step2-title">
             <a:extLst xmlns:a="http://schemas.openxmlformats.org/drawingml/2006/main">
               <a:ext uri="{FF2B5EF4-FFF2-40B4-BE49-F238E27FC236}">
-                <a16:creationId xmlns:a16="http://schemas.microsoft.com/office/drawing/2014/main" id="{FE27B2DB-5EE5-4391-9B61-EB91BE6234E7}"/>
+                <a16:creationId xmlns:a16="http://schemas.microsoft.com/office/drawing/2014/main" id="{618010DF-3EB8-45E2-8C23-F3B9D3222A98}"/>
               </a:ext>
             </a:extLst>
           </p:cNvPr>
@@ -3778,7 +3778,7 @@
           <p:cNvPr id="9" name="step2-copy">
             <a:extLst xmlns:a="http://schemas.openxmlformats.org/drawingml/2006/main">
               <a:ext uri="{FF2B5EF4-FFF2-40B4-BE49-F238E27FC236}">
-                <a16:creationId xmlns:a16="http://schemas.microsoft.com/office/drawing/2014/main" id="{595D8D1C-4E6E-4597-87DD-0BD75EB80F6F}"/>
+                <a16:creationId xmlns:a16="http://schemas.microsoft.com/office/drawing/2014/main" id="{27AA2ED6-18E2-40F5-8824-4AE7733E0C64}"/>
               </a:ext>
             </a:extLst>
           </p:cNvPr>
@@ -3828,7 +3828,7 @@
           <p:cNvPr id="10" name="evidence-box">
             <a:extLst xmlns:a="http://schemas.openxmlformats.org/drawingml/2006/main">
               <a:ext uri="{FF2B5EF4-FFF2-40B4-BE49-F238E27FC236}">
-                <a16:creationId xmlns:a16="http://schemas.microsoft.com/office/drawing/2014/main" id="{DBD8CA01-3B80-4640-92BB-7BFA1305E964}"/>
+                <a16:creationId xmlns:a16="http://schemas.microsoft.com/office/drawing/2014/main" id="{2A0CDBDD-2FD9-4F5A-8379-29A184E59EDE}"/>
               </a:ext>
             </a:extLst>
           </p:cNvPr>
@@ -3863,18 +3863,18 @@
           <p:cNvPr id="11" name="evidence-title">
             <a:extLst xmlns:a="http://schemas.openxmlformats.org/drawingml/2006/main">
               <a:ext uri="{FF2B5EF4-FFF2-40B4-BE49-F238E27FC236}">
-                <a16:creationId xmlns:a16="http://schemas.microsoft.com/office/drawing/2014/main" id="{93F43575-02DA-4FEB-BB18-F50069724539}"/>
-              </a:ext>
-            </a:extLst>
-          </p:cNvPr>
-          <p:cNvSpPr>
-            <a:spLocks xmlns:a="http://schemas.openxmlformats.org/drawingml/2006/main" noGrp="1"/>
-          </p:cNvSpPr>
-          <p:nvPr/>
-        </p:nvSpPr>
-        <p:spPr>
-          <a:xfrm xmlns:a="http://schemas.openxmlformats.org/drawingml/2006/main">
-            <a:off x="7715250" y="1885950"/>
+                <a16:creationId xmlns:a16="http://schemas.microsoft.com/office/drawing/2014/main" id="{5367984F-7A51-40C3-8F7C-A80D50C820F7}"/>
+              </a:ext>
+            </a:extLst>
+          </p:cNvPr>
+          <p:cNvSpPr>
+            <a:spLocks xmlns:a="http://schemas.openxmlformats.org/drawingml/2006/main" noGrp="1"/>
+          </p:cNvSpPr>
+          <p:nvPr/>
+        </p:nvSpPr>
+        <p:spPr>
+          <a:xfrm xmlns:a="http://schemas.openxmlformats.org/drawingml/2006/main">
+            <a:off x="7715250" y="1847850"/>
             <a:ext cx="2857500" cy="361950"/>
           </a:xfrm>
           <a:prstGeom xmlns:a="http://schemas.openxmlformats.org/drawingml/2006/main" prst="rect">
@@ -3903,29 +3903,29 @@
                   <a:srgbClr val="20251F"/>
                 </a:solidFill>
               </a:rPr>
-              <a:t>Why this is credible</a:t>
+              <a:t>dbt tests used</a:t>
             </a:r>
           </a:p>
         </p:txBody>
       </p:sp>
       <p:sp>
         <p:nvSpPr>
-          <p:cNvPr id="12" name="test-evidence">
-            <a:extLst xmlns:a="http://schemas.openxmlformats.org/drawingml/2006/main">
-              <a:ext uri="{FF2B5EF4-FFF2-40B4-BE49-F238E27FC236}">
-                <a16:creationId xmlns:a16="http://schemas.microsoft.com/office/drawing/2014/main" id="{5E98AF1E-F4EB-4338-8D1A-81F3C3EDDA70}"/>
-              </a:ext>
-            </a:extLst>
-          </p:cNvPr>
-          <p:cNvSpPr>
-            <a:spLocks xmlns:a="http://schemas.openxmlformats.org/drawingml/2006/main" noGrp="1"/>
-          </p:cNvSpPr>
-          <p:nvPr/>
-        </p:nvSpPr>
-        <p:spPr>
-          <a:xfrm xmlns:a="http://schemas.openxmlformats.org/drawingml/2006/main">
-            <a:off x="7715250" y="2476500"/>
-            <a:ext cx="2857500" cy="323850"/>
+          <p:cNvPr id="12" name="key-tests">
+            <a:extLst xmlns:a="http://schemas.openxmlformats.org/drawingml/2006/main">
+              <a:ext uri="{FF2B5EF4-FFF2-40B4-BE49-F238E27FC236}">
+                <a16:creationId xmlns:a16="http://schemas.microsoft.com/office/drawing/2014/main" id="{5A05EA63-A0DD-475B-9BE0-81FA6617FF4F}"/>
+              </a:ext>
+            </a:extLst>
+          </p:cNvPr>
+          <p:cNvSpPr>
+            <a:spLocks xmlns:a="http://schemas.openxmlformats.org/drawingml/2006/main" noGrp="1"/>
+          </p:cNvSpPr>
+          <p:nvPr/>
+        </p:nvSpPr>
+        <p:spPr>
+          <a:xfrm xmlns:a="http://schemas.openxmlformats.org/drawingml/2006/main">
+            <a:off x="7715250" y="2362200"/>
+            <a:ext cx="2952750" cy="285750"/>
           </a:xfrm>
           <a:prstGeom xmlns:a="http://schemas.openxmlformats.org/drawingml/2006/main" prst="rect">
             <a:avLst/>
@@ -3941,14 +3941,164 @@
           <a:lstStyle xmlns:a="http://schemas.openxmlformats.org/drawingml/2006/main"/>
           <a:p xmlns:a="http://schemas.openxmlformats.org/drawingml/2006/main">
             <a:pPr>
-              <a:defRPr sz="1500" b="1">
+              <a:defRPr sz="1350" b="1">
                 <a:solidFill>
                   <a:srgbClr val="69D6C8"/>
                 </a:solidFill>
               </a:defRPr>
             </a:pPr>
             <a:r>
-              <a:rPr sz="1500" b="1">
+              <a:rPr sz="1350" b="1">
+                <a:solidFill>
+                  <a:srgbClr val="69D6C8"/>
+                </a:solidFill>
+              </a:rPr>
+              <a:t>Keys: unique + not_null</a:t>
+            </a:r>
+          </a:p>
+        </p:txBody>
+      </p:sp>
+      <p:sp>
+        <p:nvSpPr>
+          <p:cNvPr id="13" name="grain-test">
+            <a:extLst xmlns:a="http://schemas.openxmlformats.org/drawingml/2006/main">
+              <a:ext uri="{FF2B5EF4-FFF2-40B4-BE49-F238E27FC236}">
+                <a16:creationId xmlns:a16="http://schemas.microsoft.com/office/drawing/2014/main" id="{29B5256C-E6C8-48CE-83E9-85F12CB173A9}"/>
+              </a:ext>
+            </a:extLst>
+          </p:cNvPr>
+          <p:cNvSpPr>
+            <a:spLocks xmlns:a="http://schemas.openxmlformats.org/drawingml/2006/main" noGrp="1"/>
+          </p:cNvSpPr>
+          <p:nvPr/>
+        </p:nvSpPr>
+        <p:spPr>
+          <a:xfrm xmlns:a="http://schemas.openxmlformats.org/drawingml/2006/main">
+            <a:off x="7715250" y="2724150"/>
+            <a:ext cx="2952750" cy="285750"/>
+          </a:xfrm>
+          <a:prstGeom xmlns:a="http://schemas.openxmlformats.org/drawingml/2006/main" prst="rect">
+            <a:avLst/>
+          </a:prstGeom>
+          <a:noFill xmlns:a="http://schemas.openxmlformats.org/drawingml/2006/main"/>
+          <a:ln xmlns:a="http://schemas.openxmlformats.org/drawingml/2006/main" w="0">
+            <a:noFill/>
+            <a:prstDash val="solid"/>
+          </a:ln>
+        </p:spPr>
+        <p:txBody>
+          <a:bodyPr xmlns:a="http://schemas.openxmlformats.org/drawingml/2006/main"/>
+          <a:lstStyle xmlns:a="http://schemas.openxmlformats.org/drawingml/2006/main"/>
+          <a:p xmlns:a="http://schemas.openxmlformats.org/drawingml/2006/main">
+            <a:pPr>
+              <a:defRPr sz="1350" b="1">
+                <a:solidFill>
+                  <a:srgbClr val="6536B4"/>
+                </a:solidFill>
+              </a:defRPr>
+            </a:pPr>
+            <a:r>
+              <a:rPr sz="1350" b="1">
+                <a:solidFill>
+                  <a:srgbClr val="6536B4"/>
+                </a:solidFill>
+              </a:rPr>
+              <a:t>Grain: date + SKU unique</a:t>
+            </a:r>
+          </a:p>
+        </p:txBody>
+      </p:sp>
+      <p:sp>
+        <p:nvSpPr>
+          <p:cNvPr id="14" name="logic-tests">
+            <a:extLst xmlns:a="http://schemas.openxmlformats.org/drawingml/2006/main">
+              <a:ext uri="{FF2B5EF4-FFF2-40B4-BE49-F238E27FC236}">
+                <a16:creationId xmlns:a16="http://schemas.microsoft.com/office/drawing/2014/main" id="{ADE9CB0D-5D23-4F50-B6CC-B2FD3596AADA}"/>
+              </a:ext>
+            </a:extLst>
+          </p:cNvPr>
+          <p:cNvSpPr>
+            <a:spLocks xmlns:a="http://schemas.openxmlformats.org/drawingml/2006/main" noGrp="1"/>
+          </p:cNvSpPr>
+          <p:nvPr/>
+        </p:nvSpPr>
+        <p:spPr>
+          <a:xfrm xmlns:a="http://schemas.openxmlformats.org/drawingml/2006/main">
+            <a:off x="7715250" y="3086100"/>
+            <a:ext cx="3143250" cy="323850"/>
+          </a:xfrm>
+          <a:prstGeom xmlns:a="http://schemas.openxmlformats.org/drawingml/2006/main" prst="rect">
+            <a:avLst/>
+          </a:prstGeom>
+          <a:noFill xmlns:a="http://schemas.openxmlformats.org/drawingml/2006/main"/>
+          <a:ln xmlns:a="http://schemas.openxmlformats.org/drawingml/2006/main" w="0">
+            <a:noFill/>
+            <a:prstDash val="solid"/>
+          </a:ln>
+        </p:spPr>
+        <p:txBody>
+          <a:bodyPr xmlns:a="http://schemas.openxmlformats.org/drawingml/2006/main"/>
+          <a:lstStyle xmlns:a="http://schemas.openxmlformats.org/drawingml/2006/main"/>
+          <a:p xmlns:a="http://schemas.openxmlformats.org/drawingml/2006/main">
+            <a:pPr>
+              <a:defRPr sz="1350" b="1">
+                <a:solidFill>
+                  <a:srgbClr val="20251F"/>
+                </a:solidFill>
+              </a:defRPr>
+            </a:pPr>
+            <a:r>
+              <a:rPr sz="1350" b="1">
+                <a:solidFill>
+                  <a:srgbClr val="20251F"/>
+                </a:solidFill>
+              </a:rPr>
+              <a:t>Logic: subtotals, profit + margin</a:t>
+            </a:r>
+          </a:p>
+        </p:txBody>
+      </p:sp>
+      <p:sp>
+        <p:nvSpPr>
+          <p:cNvPr id="15" name="test-evidence">
+            <a:extLst xmlns:a="http://schemas.openxmlformats.org/drawingml/2006/main">
+              <a:ext uri="{FF2B5EF4-FFF2-40B4-BE49-F238E27FC236}">
+                <a16:creationId xmlns:a16="http://schemas.microsoft.com/office/drawing/2014/main" id="{9BA64E94-53AB-4B1B-9B2A-130E00546331}"/>
+              </a:ext>
+            </a:extLst>
+          </p:cNvPr>
+          <p:cNvSpPr>
+            <a:spLocks xmlns:a="http://schemas.openxmlformats.org/drawingml/2006/main" noGrp="1"/>
+          </p:cNvSpPr>
+          <p:nvPr/>
+        </p:nvSpPr>
+        <p:spPr>
+          <a:xfrm xmlns:a="http://schemas.openxmlformats.org/drawingml/2006/main">
+            <a:off x="7715250" y="3524250"/>
+            <a:ext cx="2857500" cy="266700"/>
+          </a:xfrm>
+          <a:prstGeom xmlns:a="http://schemas.openxmlformats.org/drawingml/2006/main" prst="rect">
+            <a:avLst/>
+          </a:prstGeom>
+          <a:noFill xmlns:a="http://schemas.openxmlformats.org/drawingml/2006/main"/>
+          <a:ln xmlns:a="http://schemas.openxmlformats.org/drawingml/2006/main" w="0">
+            <a:noFill/>
+            <a:prstDash val="solid"/>
+          </a:ln>
+        </p:spPr>
+        <p:txBody>
+          <a:bodyPr xmlns:a="http://schemas.openxmlformats.org/drawingml/2006/main"/>
+          <a:lstStyle xmlns:a="http://schemas.openxmlformats.org/drawingml/2006/main"/>
+          <a:p xmlns:a="http://schemas.openxmlformats.org/drawingml/2006/main">
+            <a:pPr>
+              <a:defRPr sz="1275" b="1">
+                <a:solidFill>
+                  <a:srgbClr val="69D6C8"/>
+                </a:solidFill>
+              </a:defRPr>
+            </a:pPr>
+            <a:r>
+              <a:rPr sz="1275" b="1">
                 <a:solidFill>
                   <a:srgbClr val="69D6C8"/>
                 </a:solidFill>
@@ -3960,22 +4110,22 @@
       </p:sp>
       <p:sp>
         <p:nvSpPr>
-          <p:cNvPr id="13" name="recon-evidence">
-            <a:extLst xmlns:a="http://schemas.openxmlformats.org/drawingml/2006/main">
-              <a:ext uri="{FF2B5EF4-FFF2-40B4-BE49-F238E27FC236}">
-                <a16:creationId xmlns:a16="http://schemas.microsoft.com/office/drawing/2014/main" id="{B3B43B5D-2BCB-4F36-99FB-7E69FA2C5996}"/>
-              </a:ext>
-            </a:extLst>
-          </p:cNvPr>
-          <p:cNvSpPr>
-            <a:spLocks xmlns:a="http://schemas.openxmlformats.org/drawingml/2006/main" noGrp="1"/>
-          </p:cNvSpPr>
-          <p:nvPr/>
-        </p:nvSpPr>
-        <p:spPr>
-          <a:xfrm xmlns:a="http://schemas.openxmlformats.org/drawingml/2006/main">
-            <a:off x="7715250" y="3009900"/>
-            <a:ext cx="3048000" cy="514350"/>
+          <p:cNvPr id="16" name="recon-evidence">
+            <a:extLst xmlns:a="http://schemas.openxmlformats.org/drawingml/2006/main">
+              <a:ext uri="{FF2B5EF4-FFF2-40B4-BE49-F238E27FC236}">
+                <a16:creationId xmlns:a16="http://schemas.microsoft.com/office/drawing/2014/main" id="{1581FC4D-278F-461D-8759-26E929EE6EED}"/>
+              </a:ext>
+            </a:extLst>
+          </p:cNvPr>
+          <p:cNvSpPr>
+            <a:spLocks xmlns:a="http://schemas.openxmlformats.org/drawingml/2006/main" noGrp="1"/>
+          </p:cNvSpPr>
+          <p:nvPr/>
+        </p:nvSpPr>
+        <p:spPr>
+          <a:xfrm xmlns:a="http://schemas.openxmlformats.org/drawingml/2006/main">
+            <a:off x="7715250" y="3848100"/>
+            <a:ext cx="3048000" cy="266700"/>
           </a:xfrm>
           <a:prstGeom xmlns:a="http://schemas.openxmlformats.org/drawingml/2006/main" prst="rect">
             <a:avLst/>
@@ -3991,41 +4141,41 @@
           <a:lstStyle xmlns:a="http://schemas.openxmlformats.org/drawingml/2006/main"/>
           <a:p xmlns:a="http://schemas.openxmlformats.org/drawingml/2006/main">
             <a:pPr>
-              <a:defRPr sz="1500" b="1">
+              <a:defRPr sz="1275" b="1">
                 <a:solidFill>
                   <a:srgbClr val="6536B4"/>
                 </a:solidFill>
               </a:defRPr>
             </a:pPr>
             <a:r>
-              <a:rPr sz="1500" b="1">
+              <a:rPr sz="1275" b="1">
                 <a:solidFill>
                   <a:srgbClr val="6536B4"/>
                 </a:solidFill>
               </a:rPr>
-              <a:t>686 / 686 order subtotals reconciled</a:t>
+              <a:t>686 / 686 subtotals reconciled</a:t>
             </a:r>
           </a:p>
         </p:txBody>
       </p:sp>
       <p:sp>
         <p:nvSpPr>
-          <p:cNvPr id="14" name="limits-title">
-            <a:extLst xmlns:a="http://schemas.openxmlformats.org/drawingml/2006/main">
-              <a:ext uri="{FF2B5EF4-FFF2-40B4-BE49-F238E27FC236}">
-                <a16:creationId xmlns:a16="http://schemas.microsoft.com/office/drawing/2014/main" id="{DC490C6A-F019-4486-A404-7DCAD0DDC9F9}"/>
-              </a:ext>
-            </a:extLst>
-          </p:cNvPr>
-          <p:cNvSpPr>
-            <a:spLocks xmlns:a="http://schemas.openxmlformats.org/drawingml/2006/main" noGrp="1"/>
-          </p:cNvSpPr>
-          <p:nvPr/>
-        </p:nvSpPr>
-        <p:spPr>
-          <a:xfrm xmlns:a="http://schemas.openxmlformats.org/drawingml/2006/main">
-            <a:off x="7715250" y="3771900"/>
-            <a:ext cx="2667000" cy="285750"/>
+          <p:cNvPr id="17" name="limits-copy">
+            <a:extLst xmlns:a="http://schemas.openxmlformats.org/drawingml/2006/main">
+              <a:ext uri="{FF2B5EF4-FFF2-40B4-BE49-F238E27FC236}">
+                <a16:creationId xmlns:a16="http://schemas.microsoft.com/office/drawing/2014/main" id="{A67B57C9-1947-40A9-956A-2A523F76748F}"/>
+              </a:ext>
+            </a:extLst>
+          </p:cNvPr>
+          <p:cNvSpPr>
+            <a:spLocks xmlns:a="http://schemas.openxmlformats.org/drawingml/2006/main" noGrp="1"/>
+          </p:cNvSpPr>
+          <p:nvPr/>
+        </p:nvSpPr>
+        <p:spPr>
+          <a:xfrm xmlns:a="http://schemas.openxmlformats.org/drawingml/2006/main">
+            <a:off x="7715250" y="4305300"/>
+            <a:ext cx="3048000" cy="400050"/>
           </a:xfrm>
           <a:prstGeom xmlns:a="http://schemas.openxmlformats.org/drawingml/2006/main" prst="rect">
             <a:avLst/>
@@ -4041,79 +4191,29 @@
           <a:lstStyle xmlns:a="http://schemas.openxmlformats.org/drawingml/2006/main"/>
           <a:p xmlns:a="http://schemas.openxmlformats.org/drawingml/2006/main">
             <a:pPr>
-              <a:defRPr sz="1425" b="1">
-                <a:solidFill>
-                  <a:srgbClr val="20251F"/>
+              <a:defRPr sz="1200">
+                <a:solidFill>
+                  <a:srgbClr val="656B63"/>
                 </a:solidFill>
               </a:defRPr>
             </a:pPr>
             <a:r>
-              <a:rPr sz="1425" b="1">
-                <a:solidFill>
-                  <a:srgbClr val="20251F"/>
+              <a:rPr sz="1200">
+                <a:solidFill>
+                  <a:srgbClr val="656B63"/>
                 </a:solidFill>
               </a:rPr>
-              <a:t>Limits</a:t>
+              <a:t>Limits: one store, 16 days, no operating costs.</a:t>
             </a:r>
           </a:p>
         </p:txBody>
       </p:sp>
       <p:sp>
         <p:nvSpPr>
-          <p:cNvPr id="15" name="limits-copy">
-            <a:extLst xmlns:a="http://schemas.openxmlformats.org/drawingml/2006/main">
-              <a:ext uri="{FF2B5EF4-FFF2-40B4-BE49-F238E27FC236}">
-                <a16:creationId xmlns:a16="http://schemas.microsoft.com/office/drawing/2014/main" id="{164F9D6C-D745-4E1D-B6FD-012B54B95F75}"/>
-              </a:ext>
-            </a:extLst>
-          </p:cNvPr>
-          <p:cNvSpPr>
-            <a:spLocks xmlns:a="http://schemas.openxmlformats.org/drawingml/2006/main" noGrp="1"/>
-          </p:cNvSpPr>
-          <p:nvPr/>
-        </p:nvSpPr>
-        <p:spPr>
-          <a:xfrm xmlns:a="http://schemas.openxmlformats.org/drawingml/2006/main">
-            <a:off x="7715250" y="4171950"/>
-            <a:ext cx="2952750" cy="495300"/>
-          </a:xfrm>
-          <a:prstGeom xmlns:a="http://schemas.openxmlformats.org/drawingml/2006/main" prst="rect">
-            <a:avLst/>
-          </a:prstGeom>
-          <a:noFill xmlns:a="http://schemas.openxmlformats.org/drawingml/2006/main"/>
-          <a:ln xmlns:a="http://schemas.openxmlformats.org/drawingml/2006/main" w="0">
-            <a:noFill/>
-            <a:prstDash val="solid"/>
-          </a:ln>
-        </p:spPr>
-        <p:txBody>
-          <a:bodyPr xmlns:a="http://schemas.openxmlformats.org/drawingml/2006/main"/>
-          <a:lstStyle xmlns:a="http://schemas.openxmlformats.org/drawingml/2006/main"/>
-          <a:p xmlns:a="http://schemas.openxmlformats.org/drawingml/2006/main">
-            <a:pPr>
-              <a:defRPr sz="1275">
-                <a:solidFill>
-                  <a:srgbClr val="656B63"/>
-                </a:solidFill>
-              </a:defRPr>
-            </a:pPr>
-            <a:r>
-              <a:rPr sz="1275">
-                <a:solidFill>
-                  <a:srgbClr val="656B63"/>
-                </a:solidFill>
-              </a:rPr>
-              <a:t>One store. Sixteen days. No operating costs.</a:t>
-            </a:r>
-          </a:p>
-        </p:txBody>
-      </p:sp>
-      <p:sp>
-        <p:nvSpPr>
-          <p:cNvPr id="16" name="footer-rule">
-            <a:extLst xmlns:a="http://schemas.openxmlformats.org/drawingml/2006/main">
-              <a:ext uri="{FF2B5EF4-FFF2-40B4-BE49-F238E27FC236}">
-                <a16:creationId xmlns:a16="http://schemas.microsoft.com/office/drawing/2014/main" id="{9D911BED-5CDF-4D31-A311-38B84B883A5A}"/>
+          <p:cNvPr id="18" name="footer-rule">
+            <a:extLst xmlns:a="http://schemas.openxmlformats.org/drawingml/2006/main">
+              <a:ext uri="{FF2B5EF4-FFF2-40B4-BE49-F238E27FC236}">
+                <a16:creationId xmlns:a16="http://schemas.microsoft.com/office/drawing/2014/main" id="{C47AF8B5-2D79-4AB6-8140-4DEA1FA3DC9A}"/>
               </a:ext>
             </a:extLst>
           </p:cNvPr>
@@ -4143,10 +4243,10 @@
       </p:sp>
       <p:sp>
         <p:nvSpPr>
-          <p:cNvPr id="17" name="footer">
-            <a:extLst xmlns:a="http://schemas.openxmlformats.org/drawingml/2006/main">
-              <a:ext uri="{FF2B5EF4-FFF2-40B4-BE49-F238E27FC236}">
-                <a16:creationId xmlns:a16="http://schemas.microsoft.com/office/drawing/2014/main" id="{94C97CE3-0FDF-46CC-AE60-84D12F3D5129}"/>
+          <p:cNvPr id="19" name="footer">
+            <a:extLst xmlns:a="http://schemas.openxmlformats.org/drawingml/2006/main">
+              <a:ext uri="{FF2B5EF4-FFF2-40B4-BE49-F238E27FC236}">
+                <a16:creationId xmlns:a16="http://schemas.microsoft.com/office/drawing/2014/main" id="{7F8BA762-571D-4D36-B828-52E3BF955B86}"/>
               </a:ext>
             </a:extLst>
           </p:cNvPr>
@@ -4194,7 +4294,7 @@
     </p:spTree>
     <p:extLst>
       <p:ext uri="{BB962C8B-B14F-4D97-AF65-F5344CB8AC3E}">
-        <p14:creationId xmlns:p14="http://schemas.microsoft.com/office/powerpoint/2010/main" val="509715280"/>
+        <p14:creationId xmlns:p14="http://schemas.microsoft.com/office/powerpoint/2010/main" val="266713860"/>
       </p:ext>
     </p:extLst>
   </p:cSld>

</xml_diff>